<commit_message>
End every module on the about-me slide
The about-me slide in the opening and the closing Thanks slide now
share one design: the Trailhead logo, a three-line bio, and a large QR
code. Each module's Lab Debrief slide reuses that design under its own
title, so the QR code is on screen at every break.

Co-Authored-By: Claude Opus 5 (1M context) <noreply@anthropic.com>
</commit_message>
<xml_diff>
--- a/modules/M5-closing/M5-closing.pptx
+++ b/modules/M5-closing/M5-closing.pptx
@@ -40,7 +40,7 @@
     <p:sldId id="605" r:id="rId31"/>
     <p:sldId id="606" r:id="rId32"/>
     <p:sldId id="607" r:id="rId33"/>
-    <p:sldId id="540" r:id="rId34"/>
+    <p:sldId id="305" r:id="rId34"/>
   </p:sldIdLst>
   <p:sldSz cx="12192000" cy="6858000"/>
   <p:notesSz cx="6858000" cy="9144000"/>
@@ -168,10 +168,56 @@
   <pc:docChgLst>
     <pc:chgData name="J. Tower" userId="9d06de10716639e5" providerId="LiveId" clId="{F8931099-75CA-5660-A155-55881DF68D84}"/>
     <pc:docChg chg="undo redo custSel addSld delSld modSld sldOrd modSection">
-      <pc:chgData name="J. Tower" userId="9d06de10716639e5" providerId="LiveId" clId="{F8931099-75CA-5660-A155-55881DF68D84}" dt="2026-09-01T20:39:03.942" v="990" actId="20577"/>
+      <pc:chgData name="J. Tower" userId="9d06de10716639e5" providerId="LiveId" clId="{F8931099-75CA-5660-A155-55881DF68D84}" dt="2026-09-21T22:03:30.108" v="1015" actId="20577"/>
       <pc:docMkLst>
         <pc:docMk/>
       </pc:docMkLst>
+      <pc:sldChg chg="addSp delSp modSp add mod">
+        <pc:chgData name="J. Tower" userId="9d06de10716639e5" providerId="LiveId" clId="{F8931099-75CA-5660-A155-55881DF68D84}" dt="2026-09-21T22:03:30.108" v="1015" actId="20577"/>
+        <pc:sldMkLst>
+          <pc:docMk/>
+          <pc:sldMk cId="2588151616" sldId="305"/>
+        </pc:sldMkLst>
+        <pc:spChg chg="mod">
+          <ac:chgData name="J. Tower" userId="9d06de10716639e5" providerId="LiveId" clId="{F8931099-75CA-5660-A155-55881DF68D84}" dt="2026-09-21T22:03:30.108" v="1015" actId="20577"/>
+          <ac:spMkLst>
+            <pc:docMk/>
+            <pc:sldMk cId="2588151616" sldId="305"/>
+            <ac:spMk id="3" creationId="{00000000-0000-0000-0000-000000000000}"/>
+          </ac:spMkLst>
+        </pc:spChg>
+        <pc:spChg chg="add mod">
+          <ac:chgData name="J. Tower" userId="9d06de10716639e5" providerId="LiveId" clId="{F8931099-75CA-5660-A155-55881DF68D84}" dt="2026-09-21T22:02:49.307" v="994" actId="207"/>
+          <ac:spMkLst>
+            <pc:docMk/>
+            <pc:sldMk cId="2588151616" sldId="305"/>
+            <ac:spMk id="6" creationId="{AE6963CF-EE52-0F1E-6DE8-AAD1013F2522}"/>
+          </ac:spMkLst>
+        </pc:spChg>
+        <pc:spChg chg="mod">
+          <ac:chgData name="J. Tower" userId="9d06de10716639e5" providerId="LiveId" clId="{F8931099-75CA-5660-A155-55881DF68D84}" dt="2026-09-21T22:03:23.496" v="997" actId="167"/>
+          <ac:spMkLst>
+            <pc:docMk/>
+            <pc:sldMk cId="2588151616" sldId="305"/>
+            <ac:spMk id="10" creationId="{879C7D46-B427-B1BB-7A1F-392BCB232898}"/>
+          </ac:spMkLst>
+        </pc:spChg>
+        <pc:picChg chg="del">
+          <ac:chgData name="J. Tower" userId="9d06de10716639e5" providerId="LiveId" clId="{F8931099-75CA-5660-A155-55881DF68D84}" dt="2026-09-21T22:02:43.659" v="992" actId="478"/>
+          <ac:picMkLst>
+            <pc:docMk/>
+            <pc:sldMk cId="2588151616" sldId="305"/>
+            <ac:picMk id="4" creationId="{00000000-0000-0000-0000-000000000000}"/>
+          </ac:picMkLst>
+        </pc:picChg>
+      </pc:sldChg>
+      <pc:sldChg chg="del">
+        <pc:chgData name="J. Tower" userId="9d06de10716639e5" providerId="LiveId" clId="{F8931099-75CA-5660-A155-55881DF68D84}" dt="2026-09-21T22:03:10.101" v="996" actId="2696"/>
+        <pc:sldMkLst>
+          <pc:docMk/>
+          <pc:sldMk cId="934945236" sldId="540"/>
+        </pc:sldMkLst>
+      </pc:sldChg>
       <pc:sldChg chg="modSp mod">
         <pc:chgData name="J. Tower" userId="9d06de10716639e5" providerId="LiveId" clId="{F8931099-75CA-5660-A155-55881DF68D84}" dt="2026-09-01T20:37:28.584" v="981" actId="27636"/>
         <pc:sldMkLst>
@@ -355,7 +401,7 @@
           <a:p>
             <a:fld id="{4618B0EE-4D36-4F22-9622-021322CFFE3A}" type="datetimeFigureOut">
               <a:rPr lang="en-US" smtClean="0"/>
-              <a:t>9/1/26</a:t>
+              <a:t>9/21/26</a:t>
             </a:fld>
             <a:endParaRPr lang="en-US"/>
           </a:p>
@@ -2442,9 +2488,6 @@
           <a:bodyPr/>
           <a:lstStyle/>
           <a:p>
-            <a:r>
-              <a:t>Leave the framework slide up again during Q&amp;A if it's more useful than this one. The free offer (tinyurl.com/th-offer) is on this slide; point at it once.</a:t>
-            </a:r>
             <a:endParaRPr lang="en-US" dirty="0"/>
           </a:p>
         </p:txBody>
@@ -2475,7 +2518,7 @@
     </p:spTree>
     <p:extLst>
       <p:ext uri="{BB962C8B-B14F-4D97-AF65-F5344CB8AC3E}">
-        <p14:creationId xmlns:p14="http://schemas.microsoft.com/office/powerpoint/2010/main" val="987134300"/>
+        <p14:creationId xmlns:p14="http://schemas.microsoft.com/office/powerpoint/2010/main" val="2202497228"/>
       </p:ext>
     </p:extLst>
   </p:cSld>
@@ -3039,7 +3082,7 @@
             <a:fld id="{FDB08721-E45B-4A66-93A6-531BE00DB2CF}" type="datetimeFigureOut">
               <a:rPr lang="en-US" smtClean="0"/>
               <a:pPr defTabSz="342900"/>
-              <a:t>9/1/26</a:t>
+              <a:t>9/21/26</a:t>
             </a:fld>
             <a:endParaRPr lang="en-US"/>
           </a:p>
@@ -3381,7 +3424,7 @@
                 </a:solidFill>
               </a:rPr>
               <a:pPr defTabSz="342900"/>
-              <a:t>9/1/26</a:t>
+              <a:t>9/21/26</a:t>
             </a:fld>
             <a:endParaRPr lang="en-US">
               <a:solidFill>
@@ -3594,7 +3637,7 @@
                 </a:solidFill>
               </a:rPr>
               <a:pPr defTabSz="342900"/>
-              <a:t>9/1/26</a:t>
+              <a:t>9/21/26</a:t>
             </a:fld>
             <a:endParaRPr lang="en-US">
               <a:solidFill>
@@ -3797,7 +3840,7 @@
                 </a:solidFill>
               </a:rPr>
               <a:pPr defTabSz="342900"/>
-              <a:t>9/1/26</a:t>
+              <a:t>9/21/26</a:t>
             </a:fld>
             <a:endParaRPr lang="en-US">
               <a:solidFill>
@@ -4087,7 +4130,7 @@
                 </a:solidFill>
               </a:rPr>
               <a:pPr defTabSz="342900"/>
-              <a:t>9/1/26</a:t>
+              <a:t>9/21/26</a:t>
             </a:fld>
             <a:endParaRPr lang="en-US">
               <a:solidFill>
@@ -4407,7 +4450,7 @@
                 </a:solidFill>
               </a:rPr>
               <a:pPr defTabSz="342900"/>
-              <a:t>9/1/26</a:t>
+              <a:t>9/21/26</a:t>
             </a:fld>
             <a:endParaRPr lang="en-US">
               <a:solidFill>
@@ -4877,7 +4920,7 @@
                 </a:solidFill>
               </a:rPr>
               <a:pPr defTabSz="342900"/>
-              <a:t>9/1/26</a:t>
+              <a:t>9/21/26</a:t>
             </a:fld>
             <a:endParaRPr lang="en-US">
               <a:solidFill>
@@ -5029,7 +5072,7 @@
                 </a:solidFill>
               </a:rPr>
               <a:pPr defTabSz="342900"/>
-              <a:t>9/1/26</a:t>
+              <a:t>9/21/26</a:t>
             </a:fld>
             <a:endParaRPr lang="en-US">
               <a:solidFill>
@@ -5159,7 +5202,7 @@
                 </a:solidFill>
               </a:rPr>
               <a:pPr defTabSz="342900"/>
-              <a:t>9/1/26</a:t>
+              <a:t>9/21/26</a:t>
             </a:fld>
             <a:endParaRPr lang="en-US">
               <a:solidFill>
@@ -5548,7 +5591,7 @@
                 </a:solidFill>
               </a:rPr>
               <a:pPr defTabSz="342900"/>
-              <a:t>9/1/26</a:t>
+              <a:t>9/21/26</a:t>
             </a:fld>
             <a:endParaRPr lang="en-US">
               <a:solidFill>
@@ -5879,7 +5922,7 @@
             <a:fld id="{FDB08721-E45B-4A66-93A6-531BE00DB2CF}" type="datetimeFigureOut">
               <a:rPr lang="en-US" smtClean="0"/>
               <a:pPr defTabSz="342900"/>
-              <a:t>9/1/26</a:t>
+              <a:t>9/21/26</a:t>
             </a:fld>
             <a:endParaRPr lang="en-US"/>
           </a:p>
@@ -6123,7 +6166,7 @@
                 </a:solidFill>
               </a:rPr>
               <a:pPr defTabSz="342900"/>
-              <a:t>9/1/26</a:t>
+              <a:t>9/21/26</a:t>
             </a:fld>
             <a:endParaRPr lang="en-US">
               <a:solidFill>
@@ -10542,11 +10585,7 @@
           <a:p>
             <a:r>
               <a:rPr sz="2800"/>
-              <a:t>Every lab</a:t>
-            </a:r>
-            <a:r>
-              <a:rPr sz="2800"/>
-              <a:t> · every expected output</a:t>
+              <a:t>Every lab · every expected output</a:t>
             </a:r>
           </a:p>
           <a:p>
@@ -10618,7 +10657,89 @@
       </p:grpSpPr>
       <p:sp>
         <p:nvSpPr>
-          <p:cNvPr id="6" name="Content Placeholder 2"/>
+          <p:cNvPr id="10" name="Title 9">
+            <a:extLst>
+              <a:ext uri="{FF2B5EF4-FFF2-40B4-BE49-F238E27FC236}">
+                <a16:creationId xmlns:a16="http://schemas.microsoft.com/office/drawing/2014/main" id="{879C7D46-B427-B1BB-7A1F-392BCB232898}"/>
+              </a:ext>
+            </a:extLst>
+          </p:cNvPr>
+          <p:cNvSpPr>
+            <a:spLocks noGrp="1"/>
+          </p:cNvSpPr>
+          <p:nvPr>
+            <p:ph type="title"/>
+          </p:nvPr>
+        </p:nvSpPr>
+        <p:spPr>
+          <a:xfrm>
+            <a:off x="1103309" y="2776166"/>
+            <a:ext cx="10772775" cy="1658198"/>
+          </a:xfrm>
+        </p:spPr>
+        <p:txBody>
+          <a:bodyPr/>
+          <a:lstStyle/>
+          <a:p>
+            <a:r>
+              <a:rPr lang="en-US" sz="4400" dirty="0">
+                <a:solidFill>
+                  <a:schemeClr val="tx1"/>
+                </a:solidFill>
+              </a:rPr>
+              <a:t>Jonathan "J." Tower</a:t>
+            </a:r>
+            <a:endParaRPr lang="en-US" dirty="0">
+              <a:solidFill>
+                <a:schemeClr val="tx1"/>
+              </a:solidFill>
+            </a:endParaRPr>
+          </a:p>
+        </p:txBody>
+      </p:sp>
+      <p:sp>
+        <p:nvSpPr>
+          <p:cNvPr id="3" name="Content Placeholder 2"/>
+          <p:cNvSpPr>
+            <a:spLocks noGrp="1"/>
+          </p:cNvSpPr>
+          <p:nvPr>
+            <p:ph idx="1"/>
+          </p:nvPr>
+        </p:nvSpPr>
+        <p:spPr>
+          <a:xfrm>
+            <a:off x="1043180" y="4005394"/>
+            <a:ext cx="4981194" cy="456600"/>
+          </a:xfrm>
+        </p:spPr>
+        <p:txBody>
+          <a:bodyPr>
+            <a:normAutofit/>
+          </a:bodyPr>
+          <a:lstStyle/>
+          <a:p>
+            <a:pPr>
+              <a:spcBef>
+                <a:spcPts val="600"/>
+              </a:spcBef>
+            </a:pPr>
+            <a:r>
+              <a:rPr lang="en-US" sz="1800" dirty="0"/>
+              <a:t>Founding Partner</a:t>
+            </a:r>
+          </a:p>
+        </p:txBody>
+      </p:sp>
+      <p:sp>
+        <p:nvSpPr>
+          <p:cNvPr id="2" name="Content Placeholder 2">
+            <a:extLst>
+              <a:ext uri="{FF2B5EF4-FFF2-40B4-BE49-F238E27FC236}">
+                <a16:creationId xmlns:a16="http://schemas.microsoft.com/office/drawing/2014/main" id="{E5422206-0EEA-0ED9-B408-CC3FB282F987}"/>
+              </a:ext>
+            </a:extLst>
+          </p:cNvPr>
           <p:cNvSpPr txBox="1">
             <a:spLocks/>
           </p:cNvSpPr>
@@ -10626,15 +10747,15 @@
         </p:nvSpPr>
         <p:spPr>
           <a:xfrm>
-            <a:off x="6136234" y="4478455"/>
-            <a:ext cx="5293765" cy="1345294"/>
-          </a:xfrm>
-          <a:prstGeom prst="rect">
-            <a:avLst/>
-          </a:prstGeom>
-        </p:spPr>
-        <p:txBody>
-          <a:bodyPr vert="horz" lIns="91440" tIns="45720" rIns="91440" bIns="45720" rtlCol="0">
+            <a:off x="1505728" y="4419847"/>
+            <a:ext cx="3444002" cy="1251800"/>
+          </a:xfrm>
+          <a:prstGeom prst="rect">
+            <a:avLst/>
+          </a:prstGeom>
+        </p:spPr>
+        <p:txBody>
+          <a:bodyPr vert="horz" lIns="68580" tIns="34290" rIns="68580" bIns="34290" rtlCol="0">
             <a:normAutofit/>
           </a:bodyPr>
           <a:lstStyle>
@@ -10829,439 +10950,6 @@
             </a:lvl9pPr>
           </a:lstStyle>
           <a:p>
-            <a:pPr>
-              <a:tabLst>
-                <a:tab pos="233363" algn="ctr"/>
-                <a:tab pos="457200" algn="l"/>
-              </a:tabLst>
-            </a:pPr>
-            <a:endParaRPr lang="en-US" sz="2000" dirty="0"/>
-          </a:p>
-        </p:txBody>
-      </p:sp>
-      <p:sp>
-        <p:nvSpPr>
-          <p:cNvPr id="8" name="TextBox 7">
-            <a:extLst>
-              <a:ext uri="{FF2B5EF4-FFF2-40B4-BE49-F238E27FC236}">
-                <a16:creationId xmlns:a16="http://schemas.microsoft.com/office/drawing/2014/main" id="{2856C93C-026F-4286-A517-9691B6D5B7AE}"/>
-              </a:ext>
-            </a:extLst>
-          </p:cNvPr>
-          <p:cNvSpPr txBox="1"/>
-          <p:nvPr/>
-        </p:nvSpPr>
-        <p:spPr>
-          <a:xfrm>
-            <a:off x="43543" y="6165686"/>
-            <a:ext cx="12148457" cy="461665"/>
-          </a:xfrm>
-          <a:prstGeom prst="rect">
-            <a:avLst/>
-          </a:prstGeom>
-          <a:noFill/>
-        </p:spPr>
-        <p:txBody>
-          <a:bodyPr wrap="square" rtlCol="0">
-            <a:spAutoFit/>
-          </a:bodyPr>
-          <a:lstStyle/>
-          <a:p>
-            <a:pPr algn="ctr"/>
-            <a:r>
-              <a:rPr lang="en-US" sz="2400" b="1" u="sng" dirty="0" err="1">
-                <a:solidFill>
-                  <a:srgbClr val="0072C6"/>
-                </a:solidFill>
-              </a:rPr>
-              <a:t>github.com</a:t>
-            </a:r>
-            <a:r>
-              <a:rPr lang="en-US" sz="2400" b="1" u="sng" dirty="0">
-                <a:solidFill>
-                  <a:srgbClr val="0072C6"/>
-                </a:solidFill>
-              </a:rPr>
-              <a:t>/</a:t>
-            </a:r>
-            <a:r>
-              <a:rPr lang="en-US" sz="2400" b="1" u="sng" dirty="0" err="1">
-                <a:solidFill>
-                  <a:srgbClr val="0072C6"/>
-                </a:solidFill>
-              </a:rPr>
-              <a:t>trailheadtechnology</a:t>
-            </a:r>
-            <a:r>
-              <a:rPr lang="en-US" sz="2400" b="1" u="sng" dirty="0">
-                <a:solidFill>
-                  <a:srgbClr val="0072C6"/>
-                </a:solidFill>
-              </a:rPr>
-              <a:t>/10-ai-features-workshop</a:t>
-            </a:r>
-          </a:p>
-        </p:txBody>
-      </p:sp>
-      <p:sp>
-        <p:nvSpPr>
-          <p:cNvPr id="10" name="Title 9">
-            <a:extLst>
-              <a:ext uri="{FF2B5EF4-FFF2-40B4-BE49-F238E27FC236}">
-                <a16:creationId xmlns:a16="http://schemas.microsoft.com/office/drawing/2014/main" id="{879C7D46-B427-B1BB-7A1F-392BCB232898}"/>
-              </a:ext>
-            </a:extLst>
-          </p:cNvPr>
-          <p:cNvSpPr>
-            <a:spLocks noGrp="1"/>
-          </p:cNvSpPr>
-          <p:nvPr>
-            <p:ph type="title"/>
-          </p:nvPr>
-        </p:nvSpPr>
-        <p:spPr>
-          <a:xfrm>
-            <a:off x="1103309" y="499533"/>
-            <a:ext cx="10772775" cy="1658198"/>
-          </a:xfrm>
-        </p:spPr>
-        <p:txBody>
-          <a:bodyPr/>
-          <a:lstStyle/>
-          <a:p>
-            <a:r>
-              <a:rPr lang="en-US" sz="4400" dirty="0"/>
-              <a:t>Thanks! Questions?</a:t>
-            </a:r>
-            <a:endParaRPr lang="en-US" dirty="0"/>
-          </a:p>
-        </p:txBody>
-      </p:sp>
-      <p:cxnSp>
-        <p:nvCxnSpPr>
-          <p:cNvPr id="18" name="Straight Connector 17">
-            <a:extLst>
-              <a:ext uri="{FF2B5EF4-FFF2-40B4-BE49-F238E27FC236}">
-                <a16:creationId xmlns:a16="http://schemas.microsoft.com/office/drawing/2014/main" id="{CF2712ED-3129-723F-6D31-0A740072EA88}"/>
-              </a:ext>
-            </a:extLst>
-          </p:cNvPr>
-          <p:cNvCxnSpPr>
-            <a:cxnSpLocks/>
-          </p:cNvCxnSpPr>
-          <p:nvPr/>
-        </p:nvCxnSpPr>
-        <p:spPr>
-          <a:xfrm>
-            <a:off x="7032517" y="1236032"/>
-            <a:ext cx="44229" cy="4495117"/>
-          </a:xfrm>
-          <a:prstGeom prst="line">
-            <a:avLst/>
-          </a:prstGeom>
-          <a:ln>
-            <a:solidFill>
-              <a:schemeClr val="tx1"/>
-            </a:solidFill>
-          </a:ln>
-        </p:spPr>
-        <p:style>
-          <a:lnRef idx="1">
-            <a:schemeClr val="accent1"/>
-          </a:lnRef>
-          <a:fillRef idx="0">
-            <a:schemeClr val="accent1"/>
-          </a:fillRef>
-          <a:effectRef idx="0">
-            <a:schemeClr val="accent1"/>
-          </a:effectRef>
-          <a:fontRef idx="minor">
-            <a:schemeClr val="tx1"/>
-          </a:fontRef>
-        </p:style>
-      </p:cxnSp>
-      <p:sp>
-        <p:nvSpPr>
-          <p:cNvPr id="12" name="Title 9">
-            <a:extLst>
-              <a:ext uri="{FF2B5EF4-FFF2-40B4-BE49-F238E27FC236}">
-                <a16:creationId xmlns:a16="http://schemas.microsoft.com/office/drawing/2014/main" id="{C33A5900-4776-DDFB-7F43-C80F8B731FF9}"/>
-              </a:ext>
-            </a:extLst>
-          </p:cNvPr>
-          <p:cNvSpPr txBox="1">
-            <a:spLocks/>
-          </p:cNvSpPr>
-          <p:nvPr/>
-        </p:nvSpPr>
-        <p:spPr>
-          <a:xfrm>
-            <a:off x="1160202" y="2412944"/>
-            <a:ext cx="5145436" cy="1658198"/>
-          </a:xfrm>
-          <a:prstGeom prst="rect">
-            <a:avLst/>
-          </a:prstGeom>
-        </p:spPr>
-        <p:txBody>
-          <a:bodyPr vert="horz" lIns="91440" tIns="45720" rIns="91440" bIns="45720" rtlCol="0" anchor="ctr">
-            <a:normAutofit/>
-          </a:bodyPr>
-          <a:lstStyle>
-            <a:lvl1pPr algn="l" defTabSz="685800" rtl="0" eaLnBrk="1" latinLnBrk="0" hangingPunct="1">
-              <a:lnSpc>
-                <a:spcPct val="85000"/>
-              </a:lnSpc>
-              <a:spcBef>
-                <a:spcPct val="0"/>
-              </a:spcBef>
-              <a:buNone/>
-              <a:defRPr sz="4050" kern="1200" spc="-90" baseline="0">
-                <a:solidFill>
-                  <a:schemeClr val="accent1"/>
-                </a:solidFill>
-                <a:latin typeface="Segoe UI" panose="020B0502040204020203" pitchFamily="34" charset="0"/>
-                <a:ea typeface="+mj-ea"/>
-                <a:cs typeface="Segoe UI" panose="020B0502040204020203" pitchFamily="34" charset="0"/>
-              </a:defRPr>
-            </a:lvl1pPr>
-          </a:lstStyle>
-          <a:p>
-            <a:r>
-              <a:rPr lang="en-US" sz="4400" dirty="0">
-                <a:solidFill>
-                  <a:schemeClr val="tx1"/>
-                </a:solidFill>
-              </a:rPr>
-              <a:t>Jonathan "J." Tower</a:t>
-            </a:r>
-            <a:endParaRPr lang="en-US" dirty="0">
-              <a:solidFill>
-                <a:schemeClr val="tx1"/>
-              </a:solidFill>
-            </a:endParaRPr>
-          </a:p>
-        </p:txBody>
-      </p:sp>
-      <p:sp>
-        <p:nvSpPr>
-          <p:cNvPr id="9" name="Content Placeholder 2">
-            <a:extLst>
-              <a:ext uri="{FF2B5EF4-FFF2-40B4-BE49-F238E27FC236}">
-                <a16:creationId xmlns:a16="http://schemas.microsoft.com/office/drawing/2014/main" id="{2CCFC013-6D9F-96DA-4013-3CA85BB1D357}"/>
-              </a:ext>
-            </a:extLst>
-          </p:cNvPr>
-          <p:cNvSpPr txBox="1">
-            <a:spLocks/>
-          </p:cNvSpPr>
-          <p:nvPr/>
-        </p:nvSpPr>
-        <p:spPr>
-          <a:xfrm>
-            <a:off x="1505728" y="3621826"/>
-            <a:ext cx="3444002" cy="2109323"/>
-          </a:xfrm>
-          <a:prstGeom prst="rect">
-            <a:avLst/>
-          </a:prstGeom>
-        </p:spPr>
-        <p:txBody>
-          <a:bodyPr vert="horz" lIns="68580" tIns="34290" rIns="68580" bIns="34290" rtlCol="0">
-            <a:normAutofit lnSpcReduction="10000"/>
-          </a:bodyPr>
-          <a:lstStyle>
-            <a:lvl1pPr marL="91440" indent="-91440" algn="l" defTabSz="914400" rtl="0" eaLnBrk="1" latinLnBrk="0" hangingPunct="1">
-              <a:lnSpc>
-                <a:spcPct val="85000"/>
-              </a:lnSpc>
-              <a:spcBef>
-                <a:spcPts val="1300"/>
-              </a:spcBef>
-              <a:buFont typeface="Arial" pitchFamily="34" charset="0"/>
-              <a:buChar char=" "/>
-              <a:defRPr sz="2400" kern="1200">
-                <a:solidFill>
-                  <a:schemeClr val="tx1">
-                    <a:lumMod val="85000"/>
-                    <a:lumOff val="15000"/>
-                  </a:schemeClr>
-                </a:solidFill>
-                <a:latin typeface="Segoe UI" panose="020B0502040204020203" pitchFamily="34" charset="0"/>
-                <a:ea typeface="+mn-ea"/>
-                <a:cs typeface="Segoe UI" panose="020B0502040204020203" pitchFamily="34" charset="0"/>
-              </a:defRPr>
-            </a:lvl1pPr>
-            <a:lvl2pPr marL="347472" indent="-342900" algn="l" defTabSz="914400" rtl="0" eaLnBrk="1" latinLnBrk="0" hangingPunct="1">
-              <a:lnSpc>
-                <a:spcPct val="85000"/>
-              </a:lnSpc>
-              <a:spcBef>
-                <a:spcPts val="600"/>
-              </a:spcBef>
-              <a:buFont typeface="Arial" pitchFamily="34" charset="0"/>
-              <a:buChar char=" "/>
-              <a:defRPr sz="2400" kern="1200">
-                <a:solidFill>
-                  <a:schemeClr val="tx1">
-                    <a:lumMod val="85000"/>
-                    <a:lumOff val="15000"/>
-                  </a:schemeClr>
-                </a:solidFill>
-                <a:latin typeface="Segoe UI" panose="020B0502040204020203" pitchFamily="34" charset="0"/>
-                <a:ea typeface="+mn-ea"/>
-                <a:cs typeface="Segoe UI" panose="020B0502040204020203" pitchFamily="34" charset="0"/>
-              </a:defRPr>
-            </a:lvl2pPr>
-            <a:lvl3pPr marL="548640" indent="-548640" algn="l" defTabSz="914400" rtl="0" eaLnBrk="1" latinLnBrk="0" hangingPunct="1">
-              <a:lnSpc>
-                <a:spcPct val="85000"/>
-              </a:lnSpc>
-              <a:spcBef>
-                <a:spcPts val="600"/>
-              </a:spcBef>
-              <a:buFont typeface="Arial" pitchFamily="34" charset="0"/>
-              <a:buChar char=" "/>
-              <a:defRPr sz="2000" i="1" kern="1200">
-                <a:solidFill>
-                  <a:schemeClr val="tx1">
-                    <a:lumMod val="85000"/>
-                    <a:lumOff val="15000"/>
-                  </a:schemeClr>
-                </a:solidFill>
-                <a:latin typeface="Segoe UI" panose="020B0502040204020203" pitchFamily="34" charset="0"/>
-                <a:ea typeface="+mn-ea"/>
-                <a:cs typeface="Segoe UI" panose="020B0502040204020203" pitchFamily="34" charset="0"/>
-              </a:defRPr>
-            </a:lvl3pPr>
-            <a:lvl4pPr marL="822960" indent="-822960" algn="l" defTabSz="914400" rtl="0" eaLnBrk="1" latinLnBrk="0" hangingPunct="1">
-              <a:lnSpc>
-                <a:spcPct val="85000"/>
-              </a:lnSpc>
-              <a:spcBef>
-                <a:spcPts val="600"/>
-              </a:spcBef>
-              <a:buFont typeface="Arial" pitchFamily="34" charset="0"/>
-              <a:buChar char=" "/>
-              <a:defRPr sz="1800" kern="1200">
-                <a:solidFill>
-                  <a:schemeClr val="tx1">
-                    <a:lumMod val="85000"/>
-                    <a:lumOff val="15000"/>
-                  </a:schemeClr>
-                </a:solidFill>
-                <a:latin typeface="Segoe UI" panose="020B0502040204020203" pitchFamily="34" charset="0"/>
-                <a:ea typeface="+mn-ea"/>
-                <a:cs typeface="Segoe UI" panose="020B0502040204020203" pitchFamily="34" charset="0"/>
-              </a:defRPr>
-            </a:lvl4pPr>
-            <a:lvl5pPr marL="1097280" indent="-1097280" algn="l" defTabSz="914400" rtl="0" eaLnBrk="1" latinLnBrk="0" hangingPunct="1">
-              <a:lnSpc>
-                <a:spcPct val="85000"/>
-              </a:lnSpc>
-              <a:spcBef>
-                <a:spcPts val="600"/>
-              </a:spcBef>
-              <a:buFont typeface="Arial" pitchFamily="34" charset="0"/>
-              <a:buChar char=" "/>
-              <a:defRPr sz="1800" kern="1200">
-                <a:solidFill>
-                  <a:schemeClr val="tx1">
-                    <a:lumMod val="85000"/>
-                    <a:lumOff val="15000"/>
-                  </a:schemeClr>
-                </a:solidFill>
-                <a:latin typeface="Segoe UI" panose="020B0502040204020203" pitchFamily="34" charset="0"/>
-                <a:ea typeface="+mn-ea"/>
-                <a:cs typeface="Segoe UI" panose="020B0502040204020203" pitchFamily="34" charset="0"/>
-              </a:defRPr>
-            </a:lvl5pPr>
-            <a:lvl6pPr marL="1200000" indent="-228600" algn="l" defTabSz="914400" rtl="0" eaLnBrk="1" latinLnBrk="0" hangingPunct="1">
-              <a:lnSpc>
-                <a:spcPct val="85000"/>
-              </a:lnSpc>
-              <a:spcBef>
-                <a:spcPts val="600"/>
-              </a:spcBef>
-              <a:buFont typeface="Arial" pitchFamily="34" charset="0"/>
-              <a:buChar char=" "/>
-              <a:defRPr sz="1800" kern="1200">
-                <a:solidFill>
-                  <a:schemeClr val="tx1">
-                    <a:lumMod val="85000"/>
-                    <a:lumOff val="15000"/>
-                  </a:schemeClr>
-                </a:solidFill>
-                <a:latin typeface="+mn-lt"/>
-                <a:ea typeface="+mn-ea"/>
-                <a:cs typeface="+mn-cs"/>
-              </a:defRPr>
-            </a:lvl6pPr>
-            <a:lvl7pPr marL="1400000" indent="-228600" algn="l" defTabSz="914400" rtl="0" eaLnBrk="1" latinLnBrk="0" hangingPunct="1">
-              <a:lnSpc>
-                <a:spcPct val="85000"/>
-              </a:lnSpc>
-              <a:spcBef>
-                <a:spcPts val="600"/>
-              </a:spcBef>
-              <a:buFont typeface="Arial" pitchFamily="34" charset="0"/>
-              <a:buChar char=" "/>
-              <a:defRPr sz="1800" kern="1200">
-                <a:solidFill>
-                  <a:schemeClr val="tx1">
-                    <a:lumMod val="85000"/>
-                    <a:lumOff val="15000"/>
-                  </a:schemeClr>
-                </a:solidFill>
-                <a:latin typeface="+mn-lt"/>
-                <a:ea typeface="+mn-ea"/>
-                <a:cs typeface="+mn-cs"/>
-              </a:defRPr>
-            </a:lvl7pPr>
-            <a:lvl8pPr marL="1600000" indent="-228600" algn="l" defTabSz="914400" rtl="0" eaLnBrk="1" latinLnBrk="0" hangingPunct="1">
-              <a:lnSpc>
-                <a:spcPct val="85000"/>
-              </a:lnSpc>
-              <a:spcBef>
-                <a:spcPts val="600"/>
-              </a:spcBef>
-              <a:buFont typeface="Arial" pitchFamily="34" charset="0"/>
-              <a:buChar char=" "/>
-              <a:defRPr sz="1800" kern="1200">
-                <a:solidFill>
-                  <a:schemeClr val="tx1">
-                    <a:lumMod val="85000"/>
-                    <a:lumOff val="15000"/>
-                  </a:schemeClr>
-                </a:solidFill>
-                <a:latin typeface="+mn-lt"/>
-                <a:ea typeface="+mn-ea"/>
-                <a:cs typeface="+mn-cs"/>
-              </a:defRPr>
-            </a:lvl8pPr>
-            <a:lvl9pPr marL="1800000" indent="-228600" algn="l" defTabSz="914400" rtl="0" eaLnBrk="1" latinLnBrk="0" hangingPunct="1">
-              <a:lnSpc>
-                <a:spcPct val="85000"/>
-              </a:lnSpc>
-              <a:spcBef>
-                <a:spcPts val="600"/>
-              </a:spcBef>
-              <a:buFont typeface="Arial" pitchFamily="34" charset="0"/>
-              <a:buChar char=" "/>
-              <a:defRPr sz="1800" kern="1200">
-                <a:solidFill>
-                  <a:schemeClr val="tx1">
-                    <a:lumMod val="85000"/>
-                    <a:lumOff val="15000"/>
-                  </a:schemeClr>
-                </a:solidFill>
-                <a:latin typeface="+mn-lt"/>
-                <a:ea typeface="+mn-ea"/>
-                <a:cs typeface="+mn-cs"/>
-              </a:defRPr>
-            </a:lvl9pPr>
-          </a:lstStyle>
-          <a:p>
             <a:pPr marL="3429" lvl="1" indent="0" defTabSz="685800">
               <a:spcBef>
                 <a:spcPts val="975"/>
@@ -11281,7 +10969,7 @@
                   </a:prstClr>
                 </a:solidFill>
               </a:rPr>
-              <a:t>13x Microsoft MVP in .NET and AI</a:t>
+              <a:t>13x Microsoft MVP in .NET &amp; AI</a:t>
             </a:r>
           </a:p>
           <a:p>
@@ -11330,133 +11018,14 @@
               <a:t>Blue Blazes podcast host</a:t>
             </a:r>
           </a:p>
-          <a:p>
-            <a:pPr marL="0" indent="0" defTabSz="685800">
-              <a:spcBef>
-                <a:spcPts val="975"/>
-              </a:spcBef>
-              <a:buNone/>
-              <a:tabLst>
-                <a:tab pos="175022" algn="ctr"/>
-                <a:tab pos="342900" algn="l"/>
-              </a:tabLst>
-            </a:pPr>
-            <a:r>
-              <a:rPr lang="en-US" sz="1500" dirty="0" err="1">
-                <a:solidFill>
-                  <a:prstClr val="black">
-                    <a:lumMod val="85000"/>
-                    <a:lumOff val="15000"/>
-                  </a:prstClr>
-                </a:solidFill>
-              </a:rPr>
-              <a:t>jtower@trailheadtechnology.com</a:t>
-            </a:r>
-            <a:endParaRPr lang="en-US" sz="1500" dirty="0">
-              <a:solidFill>
-                <a:prstClr val="black">
-                  <a:lumMod val="85000"/>
-                  <a:lumOff val="15000"/>
-                </a:prstClr>
-              </a:solidFill>
-            </a:endParaRPr>
-          </a:p>
-          <a:p>
-            <a:pPr marL="0" indent="0" defTabSz="685800">
-              <a:spcBef>
-                <a:spcPts val="975"/>
-              </a:spcBef>
-              <a:buNone/>
-              <a:tabLst>
-                <a:tab pos="175022" algn="ctr"/>
-                <a:tab pos="342900" algn="l"/>
-              </a:tabLst>
-            </a:pPr>
-            <a:r>
-              <a:rPr lang="en-US" sz="1500" dirty="0" err="1">
-                <a:solidFill>
-                  <a:prstClr val="black">
-                    <a:lumMod val="85000"/>
-                    <a:lumOff val="15000"/>
-                  </a:prstClr>
-                </a:solidFill>
-              </a:rPr>
-              <a:t>trailheadtechnology.com</a:t>
-            </a:r>
-            <a:r>
-              <a:rPr lang="en-US" sz="1500" dirty="0">
-                <a:solidFill>
-                  <a:prstClr val="black">
-                    <a:lumMod val="85000"/>
-                    <a:lumOff val="15000"/>
-                  </a:prstClr>
-                </a:solidFill>
-              </a:rPr>
-              <a:t>/blog</a:t>
-            </a:r>
-          </a:p>
-          <a:p>
-            <a:pPr marL="0" indent="0" defTabSz="685800">
-              <a:spcBef>
-                <a:spcPts val="975"/>
-              </a:spcBef>
-              <a:buNone/>
-              <a:tabLst>
-                <a:tab pos="175022" algn="ctr"/>
-                <a:tab pos="342900" algn="l"/>
-              </a:tabLst>
-            </a:pPr>
-            <a:r>
-              <a:rPr lang="en-US" sz="1500" dirty="0" err="1">
-                <a:solidFill>
-                  <a:prstClr val="black">
-                    <a:lumMod val="85000"/>
-                    <a:lumOff val="15000"/>
-                  </a:prstClr>
-                </a:solidFill>
-              </a:rPr>
-              <a:t>jtowermi</a:t>
-            </a:r>
-            <a:endParaRPr lang="en-US" sz="1500" dirty="0">
-              <a:solidFill>
-                <a:prstClr val="black">
-                  <a:lumMod val="85000"/>
-                  <a:lumOff val="15000"/>
-                </a:prstClr>
-              </a:solidFill>
-            </a:endParaRPr>
-          </a:p>
-          <a:p>
-            <a:pPr marL="0" indent="0" defTabSz="685800">
-              <a:spcBef>
-                <a:spcPts val="975"/>
-              </a:spcBef>
-              <a:buNone/>
-              <a:tabLst>
-                <a:tab pos="175022" algn="ctr"/>
-                <a:tab pos="342900" algn="l"/>
-              </a:tabLst>
-            </a:pPr>
-            <a:r>
-              <a:rPr lang="en-US" sz="1500" dirty="0">
-                <a:solidFill>
-                  <a:prstClr val="black">
-                    <a:lumMod val="85000"/>
-                    <a:lumOff val="15000"/>
-                  </a:prstClr>
-                </a:solidFill>
-              </a:rPr>
-              <a:t>Jonathan “J.” Tower</a:t>
-            </a:r>
-          </a:p>
         </p:txBody>
       </p:sp>
       <p:pic>
         <p:nvPicPr>
-          <p:cNvPr id="11" name="Graphic 10">
+          <p:cNvPr id="5" name="Graphic 4">
             <a:extLst>
               <a:ext uri="{FF2B5EF4-FFF2-40B4-BE49-F238E27FC236}">
-                <a16:creationId xmlns:a16="http://schemas.microsoft.com/office/drawing/2014/main" id="{74691E19-F180-067C-E9F8-FBA12759EF72}"/>
+                <a16:creationId xmlns:a16="http://schemas.microsoft.com/office/drawing/2014/main" id="{5C7CF00E-0AEA-5733-E1CC-FB07798EAE61}"/>
               </a:ext>
             </a:extLst>
           </p:cNvPr>
@@ -11479,7 +11048,7 @@
         </p:blipFill>
         <p:spPr>
           <a:xfrm>
-            <a:off x="1242806" y="3631325"/>
+            <a:off x="1242806" y="4429345"/>
             <a:ext cx="229751" cy="204223"/>
           </a:xfrm>
           <a:prstGeom prst="rect">
@@ -11489,10 +11058,10 @@
       </p:pic>
       <p:pic>
         <p:nvPicPr>
-          <p:cNvPr id="15" name="Graphic 14">
+          <p:cNvPr id="13" name="Graphic 12">
             <a:extLst>
               <a:ext uri="{FF2B5EF4-FFF2-40B4-BE49-F238E27FC236}">
-                <a16:creationId xmlns:a16="http://schemas.microsoft.com/office/drawing/2014/main" id="{6CD03AF1-75DF-5384-C3B1-090D6BC361CB}"/>
+                <a16:creationId xmlns:a16="http://schemas.microsoft.com/office/drawing/2014/main" id="{90FDDDAC-FE53-8DB3-53AD-52C0E1F47DB8}"/>
               </a:ext>
             </a:extLst>
           </p:cNvPr>
@@ -11515,8 +11084,8 @@
         </p:blipFill>
         <p:spPr>
           <a:xfrm rot="155718">
-            <a:off x="1256708" y="4531226"/>
-            <a:ext cx="204223" cy="204223"/>
+            <a:off x="1281096" y="5031795"/>
+            <a:ext cx="153168" cy="204223"/>
           </a:xfrm>
           <a:prstGeom prst="rect">
             <a:avLst/>
@@ -11525,10 +11094,10 @@
       </p:pic>
       <p:pic>
         <p:nvPicPr>
-          <p:cNvPr id="16" name="Graphic 15">
+          <p:cNvPr id="19" name="Graphic 18" descr="Board Of Directors with solid fill">
             <a:extLst>
               <a:ext uri="{FF2B5EF4-FFF2-40B4-BE49-F238E27FC236}">
-                <a16:creationId xmlns:a16="http://schemas.microsoft.com/office/drawing/2014/main" id="{5D36DF01-2F6B-C32E-C484-34A5F70AA5CC}"/>
+                <a16:creationId xmlns:a16="http://schemas.microsoft.com/office/drawing/2014/main" id="{A3D1BE89-6E9F-C651-0148-6A603AE633F5}"/>
               </a:ext>
             </a:extLst>
           </p:cNvPr>
@@ -11545,14 +11114,13 @@
               </a:ext>
             </a:extLst>
           </a:blip>
-          <a:stretch>
-            <a:fillRect/>
-          </a:stretch>
+          <a:srcRect/>
+          <a:stretch/>
         </p:blipFill>
         <p:spPr>
-          <a:xfrm rot="155718">
-            <a:off x="1281096" y="4233775"/>
-            <a:ext cx="153168" cy="204223"/>
+          <a:xfrm>
+            <a:off x="1255570" y="4727557"/>
+            <a:ext cx="204223" cy="204223"/>
           </a:xfrm>
           <a:prstGeom prst="rect">
             <a:avLst/>
@@ -11561,10 +11129,10 @@
       </p:pic>
       <p:pic>
         <p:nvPicPr>
-          <p:cNvPr id="17" name="Graphic 16">
+          <p:cNvPr id="9" name="Picture 8">
             <a:extLst>
               <a:ext uri="{FF2B5EF4-FFF2-40B4-BE49-F238E27FC236}">
-                <a16:creationId xmlns:a16="http://schemas.microsoft.com/office/drawing/2014/main" id="{2F68C507-38C2-3C3C-703A-2943D69B85D8}"/>
+                <a16:creationId xmlns:a16="http://schemas.microsoft.com/office/drawing/2014/main" id="{11F84612-AE50-D33D-355E-6155EE7C1ABD}"/>
               </a:ext>
             </a:extLst>
           </p:cNvPr>
@@ -11574,140 +11142,27 @@
           <p:nvPr/>
         </p:nvPicPr>
         <p:blipFill>
-          <a:blip>
-            <a:extLst>
-              <a:ext uri="{96DAC541-7B7A-43D3-8B79-37D633B846F1}">
-                <asvg:svgBlip xmlns:asvg="http://schemas.microsoft.com/office/drawing/2016/SVG/main" r:embed="rId6"/>
-              </a:ext>
-            </a:extLst>
-          </a:blip>
+          <a:blip r:embed="rId6"/>
           <a:stretch>
             <a:fillRect/>
           </a:stretch>
         </p:blipFill>
         <p:spPr>
-          <a:xfrm rot="155718">
-            <a:off x="1255569" y="4823574"/>
-            <a:ext cx="204223" cy="204223"/>
+          <a:xfrm>
+            <a:off x="6834348" y="1134602"/>
+            <a:ext cx="4588796" cy="4588796"/>
           </a:xfrm>
           <a:prstGeom prst="rect">
             <a:avLst/>
           </a:prstGeom>
         </p:spPr>
       </p:pic>
-      <p:pic>
-        <p:nvPicPr>
-          <p:cNvPr id="19" name="Graphic 18">
+      <p:sp>
+        <p:nvSpPr>
+          <p:cNvPr id="6" name="Title 9">
             <a:extLst>
               <a:ext uri="{FF2B5EF4-FFF2-40B4-BE49-F238E27FC236}">
-                <a16:creationId xmlns:a16="http://schemas.microsoft.com/office/drawing/2014/main" id="{FAA7FFB1-1225-EE62-541D-9F7F9F6C127E}"/>
-              </a:ext>
-            </a:extLst>
-          </p:cNvPr>
-          <p:cNvPicPr>
-            <a:picLocks noChangeAspect="1"/>
-          </p:cNvPicPr>
-          <p:nvPr/>
-        </p:nvPicPr>
-        <p:blipFill>
-          <a:blip>
-            <a:extLst>
-              <a:ext uri="{96DAC541-7B7A-43D3-8B79-37D633B846F1}">
-                <asvg:svgBlip xmlns:asvg="http://schemas.microsoft.com/office/drawing/2016/SVG/main" r:embed="rId7"/>
-              </a:ext>
-            </a:extLst>
-          </a:blip>
-          <a:stretch>
-            <a:fillRect/>
-          </a:stretch>
-        </p:blipFill>
-        <p:spPr>
-          <a:xfrm rot="155718">
-            <a:off x="1276223" y="5417410"/>
-            <a:ext cx="178696" cy="204223"/>
-          </a:xfrm>
-          <a:prstGeom prst="rect">
-            <a:avLst/>
-          </a:prstGeom>
-        </p:spPr>
-      </p:pic>
-      <p:pic>
-        <p:nvPicPr>
-          <p:cNvPr id="20" name="Graphic 19">
-            <a:extLst>
-              <a:ext uri="{FF2B5EF4-FFF2-40B4-BE49-F238E27FC236}">
-                <a16:creationId xmlns:a16="http://schemas.microsoft.com/office/drawing/2014/main" id="{88CE88E4-67C7-9C99-335A-D7809B39EF73}"/>
-              </a:ext>
-            </a:extLst>
-          </p:cNvPr>
-          <p:cNvPicPr>
-            <a:picLocks noChangeAspect="1"/>
-          </p:cNvPicPr>
-          <p:nvPr/>
-        </p:nvPicPr>
-        <p:blipFill>
-          <a:blip>
-            <a:extLst>
-              <a:ext uri="{96DAC541-7B7A-43D3-8B79-37D633B846F1}">
-                <asvg:svgBlip xmlns:asvg="http://schemas.microsoft.com/office/drawing/2016/SVG/main" r:embed="rId8"/>
-              </a:ext>
-            </a:extLst>
-          </a:blip>
-          <a:stretch>
-            <a:fillRect/>
-          </a:stretch>
-        </p:blipFill>
-        <p:spPr>
-          <a:xfrm rot="155718">
-            <a:off x="1255569" y="5106312"/>
-            <a:ext cx="204223" cy="204223"/>
-          </a:xfrm>
-          <a:prstGeom prst="rect">
-            <a:avLst/>
-          </a:prstGeom>
-        </p:spPr>
-      </p:pic>
-      <p:pic>
-        <p:nvPicPr>
-          <p:cNvPr id="21" name="Graphic 20" descr="Board Of Directors with solid fill">
-            <a:extLst>
-              <a:ext uri="{FF2B5EF4-FFF2-40B4-BE49-F238E27FC236}">
-                <a16:creationId xmlns:a16="http://schemas.microsoft.com/office/drawing/2014/main" id="{52EAAC3E-0AFC-1BA5-0CF0-27F7AEFD1A64}"/>
-              </a:ext>
-            </a:extLst>
-          </p:cNvPr>
-          <p:cNvPicPr>
-            <a:picLocks noChangeAspect="1"/>
-          </p:cNvPicPr>
-          <p:nvPr/>
-        </p:nvPicPr>
-        <p:blipFill>
-          <a:blip>
-            <a:extLst>
-              <a:ext uri="{96DAC541-7B7A-43D3-8B79-37D633B846F1}">
-                <asvg:svgBlip xmlns:asvg="http://schemas.microsoft.com/office/drawing/2016/SVG/main" r:embed="rId9"/>
-              </a:ext>
-            </a:extLst>
-          </a:blip>
-          <a:srcRect/>
-          <a:stretch/>
-        </p:blipFill>
-        <p:spPr>
-          <a:xfrm>
-            <a:off x="1255570" y="3929537"/>
-            <a:ext cx="204223" cy="204223"/>
-          </a:xfrm>
-          <a:prstGeom prst="rect">
-            <a:avLst/>
-          </a:prstGeom>
-        </p:spPr>
-      </p:pic>
-      <p:sp>
-        <p:nvSpPr>
-          <p:cNvPr id="5" name="Content Placeholder 2">
-            <a:extLst>
-              <a:ext uri="{FF2B5EF4-FFF2-40B4-BE49-F238E27FC236}">
-                <a16:creationId xmlns:a16="http://schemas.microsoft.com/office/drawing/2014/main" id="{32F59F01-13CA-A538-EB00-C420909FADC1}"/>
+                <a16:creationId xmlns:a16="http://schemas.microsoft.com/office/drawing/2014/main" id="{AE6963CF-EE52-0F1E-6DE8-AAD1013F2522}"/>
               </a:ext>
             </a:extLst>
           </p:cNvPr>
@@ -11718,468 +11173,57 @@
         </p:nvSpPr>
         <p:spPr>
           <a:xfrm>
-            <a:off x="6915610" y="1050252"/>
-            <a:ext cx="5293076" cy="2240849"/>
-          </a:xfrm>
-          <a:prstGeom prst="rect">
-            <a:avLst/>
-          </a:prstGeom>
-        </p:spPr>
-        <p:txBody>
-          <a:bodyPr vert="horz" lIns="91428" tIns="45714" rIns="91428" bIns="45714" rtlCol="0">
+            <a:off x="1103309" y="499533"/>
+            <a:ext cx="10772775" cy="1658198"/>
+          </a:xfrm>
+          <a:prstGeom prst="rect">
+            <a:avLst/>
+          </a:prstGeom>
+        </p:spPr>
+        <p:txBody>
+          <a:bodyPr vert="horz" lIns="91440" tIns="45720" rIns="91440" bIns="45720" rtlCol="0" anchor="ctr">
             <a:normAutofit/>
           </a:bodyPr>
           <a:lstStyle>
-            <a:lvl1pPr marL="91440" indent="-91440" algn="l" defTabSz="914400" rtl="0" eaLnBrk="1" latinLnBrk="0" hangingPunct="1">
+            <a:lvl1pPr algn="l" defTabSz="685800" rtl="0" eaLnBrk="1" latinLnBrk="0" hangingPunct="1">
               <a:lnSpc>
                 <a:spcPct val="85000"/>
               </a:lnSpc>
               <a:spcBef>
-                <a:spcPts val="1300"/>
+                <a:spcPct val="0"/>
               </a:spcBef>
-              <a:buFont typeface="Arial" pitchFamily="34" charset="0"/>
-              <a:buChar char=" "/>
-              <a:defRPr sz="2400" kern="1200">
+              <a:buNone/>
+              <a:defRPr sz="4050" kern="1200" spc="-90" baseline="0">
                 <a:solidFill>
-                  <a:schemeClr val="tx1">
-                    <a:lumMod val="85000"/>
-                    <a:lumOff val="15000"/>
-                  </a:schemeClr>
+                  <a:srgbClr val="0070C0"/>
                 </a:solidFill>
                 <a:latin typeface="Segoe UI" panose="020B0502040204020203" pitchFamily="34" charset="0"/>
-                <a:ea typeface="+mn-ea"/>
+                <a:ea typeface="+mj-ea"/>
                 <a:cs typeface="Segoe UI" panose="020B0502040204020203" pitchFamily="34" charset="0"/>
               </a:defRPr>
             </a:lvl1pPr>
-            <a:lvl2pPr marL="347472" indent="-342900" algn="l" defTabSz="914400" rtl="0" eaLnBrk="1" latinLnBrk="0" hangingPunct="1">
-              <a:lnSpc>
-                <a:spcPct val="85000"/>
-              </a:lnSpc>
-              <a:spcBef>
-                <a:spcPts val="600"/>
-              </a:spcBef>
-              <a:buFont typeface="Arial" pitchFamily="34" charset="0"/>
-              <a:buChar char=" "/>
-              <a:defRPr sz="2400" kern="1200">
+          </a:lstStyle>
+          <a:p>
+            <a:r>
+              <a:rPr lang="en-US" sz="4400" dirty="0">
                 <a:solidFill>
-                  <a:schemeClr val="tx1">
-                    <a:lumMod val="85000"/>
-                    <a:lumOff val="15000"/>
-                  </a:schemeClr>
-                </a:solidFill>
-                <a:latin typeface="Segoe UI" panose="020B0502040204020203" pitchFamily="34" charset="0"/>
-                <a:ea typeface="+mn-ea"/>
-                <a:cs typeface="Segoe UI" panose="020B0502040204020203" pitchFamily="34" charset="0"/>
-              </a:defRPr>
-            </a:lvl2pPr>
-            <a:lvl3pPr marL="548640" indent="-548640" algn="l" defTabSz="914400" rtl="0" eaLnBrk="1" latinLnBrk="0" hangingPunct="1">
-              <a:lnSpc>
-                <a:spcPct val="85000"/>
-              </a:lnSpc>
-              <a:spcBef>
-                <a:spcPts val="600"/>
-              </a:spcBef>
-              <a:buFont typeface="Arial" pitchFamily="34" charset="0"/>
-              <a:buChar char=" "/>
-              <a:defRPr sz="2000" i="1" kern="1200">
-                <a:solidFill>
-                  <a:schemeClr val="tx1">
-                    <a:lumMod val="85000"/>
-                    <a:lumOff val="15000"/>
-                  </a:schemeClr>
-                </a:solidFill>
-                <a:latin typeface="Segoe UI" panose="020B0502040204020203" pitchFamily="34" charset="0"/>
-                <a:ea typeface="+mn-ea"/>
-                <a:cs typeface="Segoe UI" panose="020B0502040204020203" pitchFamily="34" charset="0"/>
-              </a:defRPr>
-            </a:lvl3pPr>
-            <a:lvl4pPr marL="822960" indent="-822960" algn="l" defTabSz="914400" rtl="0" eaLnBrk="1" latinLnBrk="0" hangingPunct="1">
-              <a:lnSpc>
-                <a:spcPct val="85000"/>
-              </a:lnSpc>
-              <a:spcBef>
-                <a:spcPts val="600"/>
-              </a:spcBef>
-              <a:buFont typeface="Arial" pitchFamily="34" charset="0"/>
-              <a:buChar char=" "/>
-              <a:defRPr sz="1800" kern="1200">
-                <a:solidFill>
-                  <a:schemeClr val="tx1">
-                    <a:lumMod val="85000"/>
-                    <a:lumOff val="15000"/>
-                  </a:schemeClr>
-                </a:solidFill>
-                <a:latin typeface="Segoe UI" panose="020B0502040204020203" pitchFamily="34" charset="0"/>
-                <a:ea typeface="+mn-ea"/>
-                <a:cs typeface="Segoe UI" panose="020B0502040204020203" pitchFamily="34" charset="0"/>
-              </a:defRPr>
-            </a:lvl4pPr>
-            <a:lvl5pPr marL="1097280" indent="-1097280" algn="l" defTabSz="914400" rtl="0" eaLnBrk="1" latinLnBrk="0" hangingPunct="1">
-              <a:lnSpc>
-                <a:spcPct val="85000"/>
-              </a:lnSpc>
-              <a:spcBef>
-                <a:spcPts val="600"/>
-              </a:spcBef>
-              <a:buFont typeface="Arial" pitchFamily="34" charset="0"/>
-              <a:buChar char=" "/>
-              <a:defRPr sz="1800" kern="1200">
-                <a:solidFill>
-                  <a:schemeClr val="tx1">
-                    <a:lumMod val="85000"/>
-                    <a:lumOff val="15000"/>
-                  </a:schemeClr>
-                </a:solidFill>
-                <a:latin typeface="Segoe UI" panose="020B0502040204020203" pitchFamily="34" charset="0"/>
-                <a:ea typeface="+mn-ea"/>
-                <a:cs typeface="Segoe UI" panose="020B0502040204020203" pitchFamily="34" charset="0"/>
-              </a:defRPr>
-            </a:lvl5pPr>
-            <a:lvl6pPr marL="1200000" indent="-228600" algn="l" defTabSz="914400" rtl="0" eaLnBrk="1" latinLnBrk="0" hangingPunct="1">
-              <a:lnSpc>
-                <a:spcPct val="85000"/>
-              </a:lnSpc>
-              <a:spcBef>
-                <a:spcPts val="600"/>
-              </a:spcBef>
-              <a:buFont typeface="Arial" pitchFamily="34" charset="0"/>
-              <a:buChar char=" "/>
-              <a:defRPr sz="1800" kern="1200">
-                <a:solidFill>
-                  <a:schemeClr val="tx1">
-                    <a:lumMod val="85000"/>
-                    <a:lumOff val="15000"/>
-                  </a:schemeClr>
-                </a:solidFill>
-                <a:latin typeface="+mn-lt"/>
-                <a:ea typeface="+mn-ea"/>
-                <a:cs typeface="+mn-cs"/>
-              </a:defRPr>
-            </a:lvl6pPr>
-            <a:lvl7pPr marL="1400000" indent="-228600" algn="l" defTabSz="914400" rtl="0" eaLnBrk="1" latinLnBrk="0" hangingPunct="1">
-              <a:lnSpc>
-                <a:spcPct val="85000"/>
-              </a:lnSpc>
-              <a:spcBef>
-                <a:spcPts val="600"/>
-              </a:spcBef>
-              <a:buFont typeface="Arial" pitchFamily="34" charset="0"/>
-              <a:buChar char=" "/>
-              <a:defRPr sz="1800" kern="1200">
-                <a:solidFill>
-                  <a:schemeClr val="tx1">
-                    <a:lumMod val="85000"/>
-                    <a:lumOff val="15000"/>
-                  </a:schemeClr>
-                </a:solidFill>
-                <a:latin typeface="+mn-lt"/>
-                <a:ea typeface="+mn-ea"/>
-                <a:cs typeface="+mn-cs"/>
-              </a:defRPr>
-            </a:lvl7pPr>
-            <a:lvl8pPr marL="1600000" indent="-228600" algn="l" defTabSz="914400" rtl="0" eaLnBrk="1" latinLnBrk="0" hangingPunct="1">
-              <a:lnSpc>
-                <a:spcPct val="85000"/>
-              </a:lnSpc>
-              <a:spcBef>
-                <a:spcPts val="600"/>
-              </a:spcBef>
-              <a:buFont typeface="Arial" pitchFamily="34" charset="0"/>
-              <a:buChar char=" "/>
-              <a:defRPr sz="1800" kern="1200">
-                <a:solidFill>
-                  <a:schemeClr val="tx1">
-                    <a:lumMod val="85000"/>
-                    <a:lumOff val="15000"/>
-                  </a:schemeClr>
-                </a:solidFill>
-                <a:latin typeface="+mn-lt"/>
-                <a:ea typeface="+mn-ea"/>
-                <a:cs typeface="+mn-cs"/>
-              </a:defRPr>
-            </a:lvl8pPr>
-            <a:lvl9pPr marL="1800000" indent="-228600" algn="l" defTabSz="914400" rtl="0" eaLnBrk="1" latinLnBrk="0" hangingPunct="1">
-              <a:lnSpc>
-                <a:spcPct val="85000"/>
-              </a:lnSpc>
-              <a:spcBef>
-                <a:spcPts val="600"/>
-              </a:spcBef>
-              <a:buFont typeface="Arial" pitchFamily="34" charset="0"/>
-              <a:buChar char=" "/>
-              <a:defRPr sz="1800" kern="1200">
-                <a:solidFill>
-                  <a:schemeClr val="tx1">
-                    <a:lumMod val="85000"/>
-                    <a:lumOff val="15000"/>
-                  </a:schemeClr>
-                </a:solidFill>
-                <a:latin typeface="+mn-lt"/>
-                <a:ea typeface="+mn-ea"/>
-                <a:cs typeface="+mn-cs"/>
-              </a:defRPr>
-            </a:lvl9pPr>
-          </a:lstStyle>
-          <a:p>
-            <a:pPr marL="4571" lvl="1" indent="0" algn="ctr" defTabSz="914217">
-              <a:spcBef>
-                <a:spcPts val="1300"/>
-              </a:spcBef>
-              <a:buNone/>
-              <a:tabLst>
-                <a:tab pos="233316" algn="ctr"/>
-                <a:tab pos="457109" algn="l"/>
-              </a:tabLst>
-            </a:pPr>
-            <a:r>
-              <a:rPr lang="en-US" sz="7199" dirty="0">
-                <a:solidFill>
-                  <a:prstClr val="black">
-                    <a:lumMod val="85000"/>
-                    <a:lumOff val="15000"/>
-                  </a:prstClr>
+                  <a:srgbClr val="017AB4"/>
                 </a:solidFill>
               </a:rPr>
-              <a:t>LET’S</a:t>
-            </a:r>
-            <a:br>
-              <a:rPr lang="en-US" sz="9598" b="1" dirty="0">
-                <a:solidFill>
-                  <a:prstClr val="black">
-                    <a:lumMod val="85000"/>
-                    <a:lumOff val="15000"/>
-                  </a:prstClr>
-                </a:solidFill>
-              </a:rPr>
-            </a:br>
-            <a:r>
-              <a:rPr lang="en-US" sz="7199" b="1" dirty="0">
-                <a:solidFill>
-                  <a:prstClr val="black">
-                    <a:lumMod val="85000"/>
-                    <a:lumOff val="15000"/>
-                  </a:prstClr>
-                </a:solidFill>
-              </a:rPr>
-              <a:t>TALK</a:t>
-            </a:r>
-            <a:endParaRPr lang="en-US" sz="5399" b="1" dirty="0">
+              <a:t>Thanks! Questions?</a:t>
+            </a:r>
+            <a:endParaRPr lang="en-US" dirty="0">
               <a:solidFill>
-                <a:prstClr val="black">
-                  <a:lumMod val="85000"/>
-                  <a:lumOff val="15000"/>
-                </a:prstClr>
+                <a:srgbClr val="017AB4"/>
               </a:solidFill>
             </a:endParaRPr>
           </a:p>
         </p:txBody>
       </p:sp>
-      <p:sp>
-        <p:nvSpPr>
-          <p:cNvPr id="7" name="TextBox 6">
-            <a:extLst>
-              <a:ext uri="{FF2B5EF4-FFF2-40B4-BE49-F238E27FC236}">
-                <a16:creationId xmlns:a16="http://schemas.microsoft.com/office/drawing/2014/main" id="{33E869C9-146B-DC31-A97B-A2F632A01FAF}"/>
-              </a:ext>
-            </a:extLst>
-          </p:cNvPr>
-          <p:cNvSpPr txBox="1"/>
-          <p:nvPr/>
-        </p:nvSpPr>
-        <p:spPr>
-          <a:xfrm>
-            <a:off x="6526878" y="5438564"/>
-            <a:ext cx="6104497" cy="461665"/>
-          </a:xfrm>
-          <a:prstGeom prst="rect">
-            <a:avLst/>
-          </a:prstGeom>
-          <a:noFill/>
-        </p:spPr>
-        <p:txBody>
-          <a:bodyPr wrap="square">
-            <a:spAutoFit/>
-          </a:bodyPr>
-          <a:lstStyle/>
-          <a:p>
-            <a:pPr algn="ctr"/>
-            <a:r>
-              <a:rPr lang="en-US" sz="2400" b="1" u="sng" dirty="0" err="1">
-                <a:solidFill>
-                  <a:prstClr val="black"/>
-                </a:solidFill>
-                <a:latin typeface="Calibri Light" panose="020F0302020204030204"/>
-              </a:rPr>
-              <a:t>tinyurl.com</a:t>
-            </a:r>
-            <a:r>
-              <a:rPr lang="en-US" sz="2400" b="1" u="sng" dirty="0">
-                <a:solidFill>
-                  <a:prstClr val="black"/>
-                </a:solidFill>
-                <a:latin typeface="Calibri Light" panose="020F0302020204030204"/>
-              </a:rPr>
-              <a:t>/</a:t>
-            </a:r>
-            <a:r>
-              <a:rPr lang="en-US" sz="2400" b="1" u="sng" dirty="0" err="1">
-                <a:solidFill>
-                  <a:prstClr val="black"/>
-                </a:solidFill>
-                <a:latin typeface="Calibri Light" panose="020F0302020204030204"/>
-              </a:rPr>
-              <a:t>th</a:t>
-            </a:r>
-            <a:r>
-              <a:rPr lang="en-US" sz="2400" b="1" u="sng" dirty="0">
-                <a:solidFill>
-                  <a:prstClr val="black"/>
-                </a:solidFill>
-                <a:latin typeface="Calibri Light" panose="020F0302020204030204"/>
-              </a:rPr>
-              <a:t>-offer</a:t>
-            </a:r>
-          </a:p>
-        </p:txBody>
-      </p:sp>
-      <p:grpSp>
-        <p:nvGrpSpPr>
-          <p:cNvPr id="13" name="Group 12">
-            <a:extLst>
-              <a:ext uri="{FF2B5EF4-FFF2-40B4-BE49-F238E27FC236}">
-                <a16:creationId xmlns:a16="http://schemas.microsoft.com/office/drawing/2014/main" id="{1B72D920-5FAD-6C7C-92E5-D7A6CD7728CE}"/>
-              </a:ext>
-            </a:extLst>
-          </p:cNvPr>
-          <p:cNvGrpSpPr/>
-          <p:nvPr/>
-        </p:nvGrpSpPr>
-        <p:grpSpPr>
-          <a:xfrm>
-            <a:off x="8408341" y="3028385"/>
-            <a:ext cx="2341572" cy="2341572"/>
-            <a:chOff x="15858348" y="5858285"/>
-            <a:chExt cx="4683754" cy="4683754"/>
-          </a:xfrm>
-        </p:grpSpPr>
-        <p:pic>
-          <p:nvPicPr>
-            <p:cNvPr id="14" name="Picture 13">
-              <a:extLst>
-                <a:ext uri="{FF2B5EF4-FFF2-40B4-BE49-F238E27FC236}">
-                  <a16:creationId xmlns:a16="http://schemas.microsoft.com/office/drawing/2014/main" id="{587C4335-ECF3-9DD0-6A79-CCBE00793FFA}"/>
-                </a:ext>
-              </a:extLst>
-            </p:cNvPr>
-            <p:cNvPicPr>
-              <a:picLocks noChangeAspect="1"/>
-            </p:cNvPicPr>
-            <p:nvPr/>
-          </p:nvPicPr>
-          <p:blipFill>
-            <a:blip r:embed="rId10"/>
-            <a:stretch>
-              <a:fillRect/>
-            </a:stretch>
-          </p:blipFill>
-          <p:spPr>
-            <a:xfrm>
-              <a:off x="15858348" y="5858285"/>
-              <a:ext cx="4683754" cy="4683754"/>
-            </a:xfrm>
-            <a:prstGeom prst="rect">
-              <a:avLst/>
-            </a:prstGeom>
-          </p:spPr>
-        </p:pic>
-        <p:sp>
-          <p:nvSpPr>
-            <p:cNvPr id="22" name="Rectangle 21">
-              <a:extLst>
-                <a:ext uri="{FF2B5EF4-FFF2-40B4-BE49-F238E27FC236}">
-                  <a16:creationId xmlns:a16="http://schemas.microsoft.com/office/drawing/2014/main" id="{78756400-64DF-EB40-AC83-0458252B366C}"/>
-                </a:ext>
-              </a:extLst>
-            </p:cNvPr>
-            <p:cNvSpPr/>
-            <p:nvPr/>
-          </p:nvSpPr>
-          <p:spPr>
-            <a:xfrm>
-              <a:off x="17416130" y="7421526"/>
-              <a:ext cx="1658679" cy="1535384"/>
-            </a:xfrm>
-            <a:prstGeom prst="rect">
-              <a:avLst/>
-            </a:prstGeom>
-            <a:solidFill>
-              <a:schemeClr val="bg1"/>
-            </a:solidFill>
-            <a:ln>
-              <a:noFill/>
-            </a:ln>
-          </p:spPr>
-          <p:style>
-            <a:lnRef idx="2">
-              <a:schemeClr val="accent1">
-                <a:shade val="15000"/>
-              </a:schemeClr>
-            </a:lnRef>
-            <a:fillRef idx="1">
-              <a:schemeClr val="accent1"/>
-            </a:fillRef>
-            <a:effectRef idx="0">
-              <a:schemeClr val="accent1"/>
-            </a:effectRef>
-            <a:fontRef idx="minor">
-              <a:schemeClr val="lt1"/>
-            </a:fontRef>
-          </p:style>
-          <p:txBody>
-            <a:bodyPr rtlCol="0" anchor="ctr"/>
-            <a:lstStyle/>
-            <a:p>
-              <a:pPr algn="ctr"/>
-              <a:endParaRPr lang="en-US" sz="900"/>
-            </a:p>
-          </p:txBody>
-        </p:sp>
-        <p:pic>
-          <p:nvPicPr>
-            <p:cNvPr id="23" name="Picture 22">
-              <a:extLst>
-                <a:ext uri="{FF2B5EF4-FFF2-40B4-BE49-F238E27FC236}">
-                  <a16:creationId xmlns:a16="http://schemas.microsoft.com/office/drawing/2014/main" id="{2811BA38-866A-6911-EB15-652F44639437}"/>
-                </a:ext>
-              </a:extLst>
-            </p:cNvPr>
-            <p:cNvPicPr>
-              <a:picLocks noChangeAspect="1"/>
-            </p:cNvPicPr>
-            <p:nvPr/>
-          </p:nvPicPr>
-          <p:blipFill>
-            <a:blip r:embed="rId11"/>
-            <a:srcRect r="73380" b="-4670"/>
-            <a:stretch>
-              <a:fillRect/>
-            </a:stretch>
-          </p:blipFill>
-          <p:spPr>
-            <a:xfrm>
-              <a:off x="17543720" y="7496969"/>
-              <a:ext cx="1360997" cy="1413229"/>
-            </a:xfrm>
-            <a:prstGeom prst="rect">
-              <a:avLst/>
-            </a:prstGeom>
-          </p:spPr>
-        </p:pic>
-      </p:grpSp>
     </p:spTree>
     <p:extLst>
       <p:ext uri="{BB962C8B-B14F-4D97-AF65-F5344CB8AC3E}">
-        <p14:creationId xmlns:p14="http://schemas.microsoft.com/office/powerpoint/2010/main" val="934945236"/>
+        <p14:creationId xmlns:p14="http://schemas.microsoft.com/office/powerpoint/2010/main" val="2588151616"/>
       </p:ext>
     </p:extLst>
   </p:cSld>

</xml_diff>